<commit_message>
feat: remove temporary PowerPoint file and add new AIC reticle JSON and utility scripts
This commit deletes the temporary PowerPoint file related to the M3' Up*/Down* architecture and introduces a new JSON file detailing the AIC reticle metrics. Additionally, it adds utility scripts for handling collectives on the AIC reticle fabric, enhancing the analysis and routing capabilities within the architecture. These updates aim to streamline the project structure and improve the overall functionality of the analysis tools.
</commit_message>
<xml_diff>
--- a/results/pg_m3p_updown_slide.pptx
+++ b/results/pg_m3p_updown_slide.pptx
@@ -22138,22 +22138,13 @@
               <a:t> 293 bit/router </a:t>
             </a:r>
             <a:r>
-              <a:rPr sz="1000" b="0">
-                <a:solidFill>
-                  <a:srgbClr val="C3CBD4"/>
-                </a:solidFill>
-                <a:latin typeface="Microsoft YaHei"/>
-              </a:rPr>
-              <a:t>的表</a:t>
-            </a:r>
-            <a:r>
               <a:rPr sz="1000" b="0" dirty="0" err="1">
                 <a:solidFill>
                   <a:srgbClr val="C3CBD4"/>
                 </a:solidFill>
                 <a:latin typeface="Microsoft YaHei"/>
               </a:rPr>
-              <a:t>（每节点存储的</a:t>
+              <a:t>的表（每节点存储的</a:t>
             </a:r>
             <a:r>
               <a:rPr sz="1000" b="0" dirty="0">

</xml_diff>